<commit_message>
docs: API Platform command references run through docker/sdk cli
The commands reference of the Glue guide, the intermediate presentation and
the setup guide listed bare glue commands; they only work inside the CLI
container. Also adds glue cache:clear to the presentation table.

Co-Authored-By: Claude Opus 5.5 <noreply@anthropic.com>
</commit_message>
<xml_diff>
--- a/guides-pptx/spryker-academy-professional.pptx
+++ b/guides-pptx/spryker-academy-professional.pptx
@@ -13633,7 +13633,7 @@
               </a:defRPr>
             </a:pPr>
             <a:r>
-              <a:t>Command                                                        Purpose                                                                                                           </a:t>
+              <a:t>Command                                                                       Purpose                                                                                                           </a:t>
             </a:r>
           </a:p>
           <a:p>
@@ -13649,7 +13649,7 @@
               </a:defRPr>
             </a:pPr>
             <a:r>
-              <a:t>-------------------------------------------------------------  ------------------------------------------------------------------------------------------------------------------</a:t>
+              <a:t>----------------------------------------------------------------------------  ------------------------------------------------------------------------------------------------------------------</a:t>
             </a:r>
           </a:p>
           <a:p>
@@ -13665,7 +13665,7 @@
               </a:defRPr>
             </a:pPr>
             <a:r>
-              <a:t>GLUE_APPLICATION=GLUE glue api:generate storefront             Generate Storefront API resources                                                                                 </a:t>
+              <a:t>docker/sdk cli GLUE_APPLICATION=GLUE glue api:generate storefront             Generate Storefront API resources                                                                                 </a:t>
             </a:r>
           </a:p>
           <a:p>
@@ -13681,7 +13681,7 @@
               </a:defRPr>
             </a:pPr>
             <a:r>
-              <a:t>GLUE_APPLICATION=GLUE_BACKEND glue api:generate backend        Generate Backend API resources                                                                                    </a:t>
+              <a:t>docker/sdk cli GLUE_APPLICATION=GLUE_BACKEND glue api:generate backend        Generate Backend API resources                                                                                    </a:t>
             </a:r>
           </a:p>
           <a:p>
@@ -13697,7 +13697,7 @@
               </a:defRPr>
             </a:pPr>
             <a:r>
-              <a:t>GLUE_APPLICATION=GLUE glue cache:clear                         Delete the compiled Glue container and its metadata cache, so the next request reads the generated resources again</a:t>
+              <a:t>docker/sdk cli GLUE_APPLICATION=GLUE glue cache:clear                         Delete the compiled Glue container and its metadata cache, so the next request reads the generated resources again</a:t>
             </a:r>
           </a:p>
           <a:p>
@@ -13713,7 +13713,7 @@
               </a:defRPr>
             </a:pPr>
             <a:r>
-              <a:t>GLUE_APPLICATION=GLUE glue api:generate --dry-run              Preview what would be generated without writing                                                                   </a:t>
+              <a:t>docker/sdk cli GLUE_APPLICATION=GLUE glue api:generate --dry-run              Preview what would be generated without writing                                                                   </a:t>
             </a:r>
           </a:p>
           <a:p>
@@ -13729,7 +13729,7 @@
               </a:defRPr>
             </a:pPr>
             <a:r>
-              <a:t>GLUE_APPLICATION=GLUE glue api:generate --validate-only        Validate schemas without generating                                                                               </a:t>
+              <a:t>docker/sdk cli GLUE_APPLICATION=GLUE glue api:generate --validate-only        Validate schemas without generating                                                                               </a:t>
             </a:r>
           </a:p>
           <a:p>
@@ -13745,7 +13745,7 @@
               </a:defRPr>
             </a:pPr>
             <a:r>
-              <a:t>GLUE_APPLICATION=GLUE glue api:generate -r suppliers           Generate only the suppliers resource                                                                              </a:t>
+              <a:t>docker/sdk cli GLUE_APPLICATION=GLUE glue api:generate -r suppliers           Generate only the suppliers resource                                                                              </a:t>
             </a:r>
           </a:p>
           <a:p>
@@ -13761,7 +13761,7 @@
               </a:defRPr>
             </a:pPr>
             <a:r>
-              <a:t>GLUE_APPLICATION=GLUE glue api:debug --list                    List all registered resources                                                                                     </a:t>
+              <a:t>docker/sdk cli GLUE_APPLICATION=GLUE glue api:debug --list                    List all registered resources                                                                                     </a:t>
             </a:r>
           </a:p>
           <a:p>
@@ -13777,7 +13777,7 @@
               </a:defRPr>
             </a:pPr>
             <a:r>
-              <a:t>GLUE_APPLICATION=GLUE glue api:debug suppliers                 Inspect a specific resource’s merged schema                                                                       </a:t>
+              <a:t>docker/sdk cli GLUE_APPLICATION=GLUE glue api:debug suppliers                 Inspect a specific resource’s merged schema                                                                       </a:t>
             </a:r>
           </a:p>
           <a:p>
@@ -13793,7 +13793,7 @@
               </a:defRPr>
             </a:pPr>
             <a:r>
-              <a:t>GLUE_APPLICATION=GLUE glue api:debug suppliers --show-sources  Show all source files with priority                                                                               </a:t>
+              <a:t>docker/sdk cli GLUE_APPLICATION=GLUE glue api:debug suppliers --show-sources  Show all source files with priority                                                                               </a:t>
             </a:r>
           </a:p>
           <a:p>
@@ -13809,7 +13809,7 @@
               </a:defRPr>
             </a:pPr>
             <a:r>
-              <a:t>GLUE_APPLICATION=GLUE glue api:debug suppliers --show-merged   Display the final merged YAML schema</a:t>
+              <a:t>docker/sdk cli GLUE_APPLICATION=GLUE glue api:debug suppliers --show-merged   Display the final merged YAML schema</a:t>
             </a:r>
           </a:p>
           <a:p>
@@ -13824,7 +13824,7 @@
               </a:defRPr>
             </a:pPr>
             <a:r>
-              <a:t>❝ Tip: All glue CLI commands require the GLUE_APPLICATION env var. Prefix every command with GLUE_APPLICATION=GLUE (the storefront API of this shop) or GLUE_APPLICATION=GLUE_BACKEND as needed.</a:t>
+              <a:t>❝ Tip: All glue CLI commands require the GLUE_APPLICATION env var. Run them inside the CLI container with docker/sdk cli and prefix every command with GLUE_APPLICATION=GLUE (the storefront API of this shop) or GLUE_APPLICATION=GLUE_BACKEND as needed.</a:t>
             </a:r>
           </a:p>
         </p:txBody>

</xml_diff>